<commit_message>
Deck: add 7th team member (Sameer Kohli) + rebalance to a 4+3 grid
Slide 2 now lists all seven members in order — Srujan K, Satish B, Renuka
Jataprolu, Saumya Ratan, Priyanka Laha, Santosh Vaddadi, Sameer Kohli — in a
centered 4-over-3 grid (Sameer gets a coral avatar). Subtitle updated to
seven-member. Verified via LibreOffice render (02/23, presenting-to band intact).

Co-Authored-By: Claude Opus 4.8 <noreply@anthropic.com>
</commit_message>
<xml_diff>
--- a/presentation/Helix_Project_Deck.pptx
+++ b/presentation/Helix_Project_Deck.pptx
@@ -16283,7 +16283,7 @@
                 </a:solidFill>
                 <a:latin typeface="Segoe UI"/>
               </a:rPr>
-              <a:t>A six-member capstone group · IIIT-Hyderabad · 2026</a:t>
+              <a:t>A seven-member capstone group · IIIT-Hyderabad · 2026</a:t>
             </a:r>
           </a:p>
         </p:txBody>
@@ -16296,8 +16296,8 @@
         </p:nvSpPr>
         <p:spPr>
           <a:xfrm>
-            <a:off x="914400" y="2468880"/>
-            <a:ext cx="3246120" cy="1143000"/>
+            <a:off x="636879" y="2432304"/>
+            <a:ext cx="2606040" cy="1097280"/>
           </a:xfrm>
           <a:prstGeom prst="roundRect">
             <a:avLst>
@@ -16344,8 +16344,8 @@
         </p:nvSpPr>
         <p:spPr>
           <a:xfrm>
-            <a:off x="1207008" y="2788920"/>
-            <a:ext cx="502920" cy="502920"/>
+            <a:off x="874623" y="2752344"/>
+            <a:ext cx="457200" cy="457200"/>
           </a:xfrm>
           <a:prstGeom prst="ellipse">
             <a:avLst/>
@@ -16388,8 +16388,8 @@
         </p:nvSpPr>
         <p:spPr>
           <a:xfrm>
-            <a:off x="1207008" y="2788920"/>
-            <a:ext cx="502920" cy="502920"/>
+            <a:off x="874623" y="2752344"/>
+            <a:ext cx="457200" cy="457200"/>
           </a:xfrm>
           <a:prstGeom prst="rect">
             <a:avLst/>
@@ -16408,7 +16408,7 @@
               </a:spcAft>
             </a:pPr>
             <a:r>
-              <a:rPr sz="1400" b="1">
+              <a:rPr sz="1200" b="1">
                 <a:solidFill>
                   <a:srgbClr val="04060F"/>
                 </a:solidFill>
@@ -16427,8 +16427,8 @@
         </p:nvSpPr>
         <p:spPr>
           <a:xfrm>
-            <a:off x="1874519" y="2743200"/>
-            <a:ext cx="2194560" cy="594360"/>
+            <a:off x="1441551" y="2670048"/>
+            <a:ext cx="1645920" cy="621792"/>
           </a:xfrm>
           <a:prstGeom prst="rect">
             <a:avLst/>
@@ -16447,7 +16447,7 @@
               </a:spcAft>
             </a:pPr>
             <a:r>
-              <a:rPr sz="1500" b="1">
+              <a:rPr sz="1300" b="1">
                 <a:solidFill>
                   <a:srgbClr val="FFFFFF"/>
                 </a:solidFill>
@@ -16466,8 +16466,8 @@
         </p:nvSpPr>
         <p:spPr>
           <a:xfrm>
-            <a:off x="4434840" y="2468880"/>
-            <a:ext cx="3246120" cy="1143000"/>
+            <a:off x="3407511" y="2432304"/>
+            <a:ext cx="2606040" cy="1097280"/>
           </a:xfrm>
           <a:prstGeom prst="roundRect">
             <a:avLst>
@@ -16514,8 +16514,8 @@
         </p:nvSpPr>
         <p:spPr>
           <a:xfrm>
-            <a:off x="4727448" y="2788920"/>
-            <a:ext cx="502920" cy="502920"/>
+            <a:off x="3645255" y="2752344"/>
+            <a:ext cx="457200" cy="457200"/>
           </a:xfrm>
           <a:prstGeom prst="ellipse">
             <a:avLst/>
@@ -16558,8 +16558,8 @@
         </p:nvSpPr>
         <p:spPr>
           <a:xfrm>
-            <a:off x="4727448" y="2788920"/>
-            <a:ext cx="502920" cy="502920"/>
+            <a:off x="3645255" y="2752344"/>
+            <a:ext cx="457200" cy="457200"/>
           </a:xfrm>
           <a:prstGeom prst="rect">
             <a:avLst/>
@@ -16578,7 +16578,7 @@
               </a:spcAft>
             </a:pPr>
             <a:r>
-              <a:rPr sz="1400" b="1">
+              <a:rPr sz="1200" b="1">
                 <a:solidFill>
                   <a:srgbClr val="04060F"/>
                 </a:solidFill>
@@ -16597,8 +16597,8 @@
         </p:nvSpPr>
         <p:spPr>
           <a:xfrm>
-            <a:off x="5394959" y="2743200"/>
-            <a:ext cx="2194560" cy="594360"/>
+            <a:off x="4212183" y="2670048"/>
+            <a:ext cx="1645920" cy="621792"/>
           </a:xfrm>
           <a:prstGeom prst="rect">
             <a:avLst/>
@@ -16617,7 +16617,7 @@
               </a:spcAft>
             </a:pPr>
             <a:r>
-              <a:rPr sz="1500" b="1">
+              <a:rPr sz="1300" b="1">
                 <a:solidFill>
                   <a:srgbClr val="FFFFFF"/>
                 </a:solidFill>
@@ -16636,8 +16636,8 @@
         </p:nvSpPr>
         <p:spPr>
           <a:xfrm>
-            <a:off x="7955279" y="2468880"/>
-            <a:ext cx="3246120" cy="1143000"/>
+            <a:off x="6178143" y="2432304"/>
+            <a:ext cx="2606040" cy="1097280"/>
           </a:xfrm>
           <a:prstGeom prst="roundRect">
             <a:avLst>
@@ -16684,8 +16684,8 @@
         </p:nvSpPr>
         <p:spPr>
           <a:xfrm>
-            <a:off x="8247888" y="2788920"/>
-            <a:ext cx="502920" cy="502920"/>
+            <a:off x="6415887" y="2752344"/>
+            <a:ext cx="457200" cy="457200"/>
           </a:xfrm>
           <a:prstGeom prst="ellipse">
             <a:avLst/>
@@ -16728,8 +16728,8 @@
         </p:nvSpPr>
         <p:spPr>
           <a:xfrm>
-            <a:off x="8247888" y="2788920"/>
-            <a:ext cx="502920" cy="502920"/>
+            <a:off x="6415887" y="2752344"/>
+            <a:ext cx="457200" cy="457200"/>
           </a:xfrm>
           <a:prstGeom prst="rect">
             <a:avLst/>
@@ -16748,7 +16748,7 @@
               </a:spcAft>
             </a:pPr>
             <a:r>
-              <a:rPr sz="1400" b="1">
+              <a:rPr sz="1200" b="1">
                 <a:solidFill>
                   <a:srgbClr val="04060F"/>
                 </a:solidFill>
@@ -16767,8 +16767,8 @@
         </p:nvSpPr>
         <p:spPr>
           <a:xfrm>
-            <a:off x="8915400" y="2743200"/>
-            <a:ext cx="2194560" cy="594360"/>
+            <a:off x="6982815" y="2670048"/>
+            <a:ext cx="1645920" cy="621792"/>
           </a:xfrm>
           <a:prstGeom prst="rect">
             <a:avLst/>
@@ -16787,7 +16787,7 @@
               </a:spcAft>
             </a:pPr>
             <a:r>
-              <a:rPr sz="1500" b="1">
+              <a:rPr sz="1300" b="1">
                 <a:solidFill>
                   <a:srgbClr val="FFFFFF"/>
                 </a:solidFill>
@@ -16806,8 +16806,8 @@
         </p:nvSpPr>
         <p:spPr>
           <a:xfrm>
-            <a:off x="914400" y="3794760"/>
-            <a:ext cx="3246120" cy="1143000"/>
+            <a:off x="8948775" y="2432304"/>
+            <a:ext cx="2606040" cy="1097280"/>
           </a:xfrm>
           <a:prstGeom prst="roundRect">
             <a:avLst>
@@ -16854,8 +16854,8 @@
         </p:nvSpPr>
         <p:spPr>
           <a:xfrm>
-            <a:off x="1207008" y="4114800"/>
-            <a:ext cx="502920" cy="502920"/>
+            <a:off x="9186519" y="2752344"/>
+            <a:ext cx="457200" cy="457200"/>
           </a:xfrm>
           <a:prstGeom prst="ellipse">
             <a:avLst/>
@@ -16898,8 +16898,8 @@
         </p:nvSpPr>
         <p:spPr>
           <a:xfrm>
-            <a:off x="1207008" y="4114800"/>
-            <a:ext cx="502920" cy="502920"/>
+            <a:off x="9186519" y="2752344"/>
+            <a:ext cx="457200" cy="457200"/>
           </a:xfrm>
           <a:prstGeom prst="rect">
             <a:avLst/>
@@ -16918,7 +16918,7 @@
               </a:spcAft>
             </a:pPr>
             <a:r>
-              <a:rPr sz="1400" b="1">
+              <a:rPr sz="1200" b="1">
                 <a:solidFill>
                   <a:srgbClr val="04060F"/>
                 </a:solidFill>
@@ -16937,8 +16937,8 @@
         </p:nvSpPr>
         <p:spPr>
           <a:xfrm>
-            <a:off x="1874519" y="4069080"/>
-            <a:ext cx="2194560" cy="594360"/>
+            <a:off x="9753447" y="2670048"/>
+            <a:ext cx="1645920" cy="621792"/>
           </a:xfrm>
           <a:prstGeom prst="rect">
             <a:avLst/>
@@ -16957,7 +16957,7 @@
               </a:spcAft>
             </a:pPr>
             <a:r>
-              <a:rPr sz="1500" b="1">
+              <a:rPr sz="1300" b="1">
                 <a:solidFill>
                   <a:srgbClr val="FFFFFF"/>
                 </a:solidFill>
@@ -16976,8 +16976,8 @@
         </p:nvSpPr>
         <p:spPr>
           <a:xfrm>
-            <a:off x="4434840" y="3794760"/>
-            <a:ext cx="3246120" cy="1143000"/>
+            <a:off x="2022195" y="3712464"/>
+            <a:ext cx="2606040" cy="1097280"/>
           </a:xfrm>
           <a:prstGeom prst="roundRect">
             <a:avLst>
@@ -17024,8 +17024,8 @@
         </p:nvSpPr>
         <p:spPr>
           <a:xfrm>
-            <a:off x="4727448" y="4114800"/>
-            <a:ext cx="502920" cy="502920"/>
+            <a:off x="2259939" y="4032504"/>
+            <a:ext cx="457200" cy="457200"/>
           </a:xfrm>
           <a:prstGeom prst="ellipse">
             <a:avLst/>
@@ -17068,8 +17068,8 @@
         </p:nvSpPr>
         <p:spPr>
           <a:xfrm>
-            <a:off x="4727448" y="4114800"/>
-            <a:ext cx="502920" cy="502920"/>
+            <a:off x="2259939" y="4032504"/>
+            <a:ext cx="457200" cy="457200"/>
           </a:xfrm>
           <a:prstGeom prst="rect">
             <a:avLst/>
@@ -17088,7 +17088,7 @@
               </a:spcAft>
             </a:pPr>
             <a:r>
-              <a:rPr sz="1400" b="1">
+              <a:rPr sz="1200" b="1">
                 <a:solidFill>
                   <a:srgbClr val="04060F"/>
                 </a:solidFill>
@@ -17107,8 +17107,8 @@
         </p:nvSpPr>
         <p:spPr>
           <a:xfrm>
-            <a:off x="5394959" y="4069080"/>
-            <a:ext cx="2194560" cy="594360"/>
+            <a:off x="2826867" y="3950208"/>
+            <a:ext cx="1645920" cy="621792"/>
           </a:xfrm>
           <a:prstGeom prst="rect">
             <a:avLst/>
@@ -17127,7 +17127,7 @@
               </a:spcAft>
             </a:pPr>
             <a:r>
-              <a:rPr sz="1500" b="1">
+              <a:rPr sz="1300" b="1">
                 <a:solidFill>
                   <a:srgbClr val="FFFFFF"/>
                 </a:solidFill>
@@ -17146,8 +17146,8 @@
         </p:nvSpPr>
         <p:spPr>
           <a:xfrm>
-            <a:off x="7955279" y="3794760"/>
-            <a:ext cx="3246120" cy="1143000"/>
+            <a:off x="4792827" y="3712464"/>
+            <a:ext cx="2606040" cy="1097280"/>
           </a:xfrm>
           <a:prstGeom prst="roundRect">
             <a:avLst>
@@ -17194,8 +17194,8 @@
         </p:nvSpPr>
         <p:spPr>
           <a:xfrm>
-            <a:off x="8247888" y="4114800"/>
-            <a:ext cx="502920" cy="502920"/>
+            <a:off x="5030571" y="4032504"/>
+            <a:ext cx="457200" cy="457200"/>
           </a:xfrm>
           <a:prstGeom prst="ellipse">
             <a:avLst/>
@@ -17238,8 +17238,8 @@
         </p:nvSpPr>
         <p:spPr>
           <a:xfrm>
-            <a:off x="8247888" y="4114800"/>
-            <a:ext cx="502920" cy="502920"/>
+            <a:off x="5030571" y="4032504"/>
+            <a:ext cx="457200" cy="457200"/>
           </a:xfrm>
           <a:prstGeom prst="rect">
             <a:avLst/>
@@ -17258,7 +17258,7 @@
               </a:spcAft>
             </a:pPr>
             <a:r>
-              <a:rPr sz="1400" b="1">
+              <a:rPr sz="1200" b="1">
                 <a:solidFill>
                   <a:srgbClr val="04060F"/>
                 </a:solidFill>
@@ -17277,8 +17277,8 @@
         </p:nvSpPr>
         <p:spPr>
           <a:xfrm>
-            <a:off x="8915400" y="4069080"/>
-            <a:ext cx="2194560" cy="594360"/>
+            <a:off x="5597499" y="3950208"/>
+            <a:ext cx="1645920" cy="621792"/>
           </a:xfrm>
           <a:prstGeom prst="rect">
             <a:avLst/>
@@ -17297,7 +17297,7 @@
               </a:spcAft>
             </a:pPr>
             <a:r>
-              <a:rPr sz="1500" b="1">
+              <a:rPr sz="1300" b="1">
                 <a:solidFill>
                   <a:srgbClr val="FFFFFF"/>
                 </a:solidFill>
@@ -17316,8 +17316,178 @@
         </p:nvSpPr>
         <p:spPr>
           <a:xfrm>
-            <a:off x="914400" y="5230368"/>
-            <a:ext cx="10360152" cy="1005840"/>
+            <a:off x="7563459" y="3712464"/>
+            <a:ext cx="2606040" cy="1097280"/>
+          </a:xfrm>
+          <a:prstGeom prst="roundRect">
+            <a:avLst>
+              <a:gd name="adj" fmla="val 8000"/>
+            </a:avLst>
+          </a:prstGeom>
+          <a:solidFill>
+            <a:srgbClr val="0C1224"/>
+          </a:solidFill>
+          <a:ln w="12700">
+            <a:solidFill>
+              <a:srgbClr val="1A2440"/>
+            </a:solidFill>
+          </a:ln>
+          <a:effectLst/>
+        </p:spPr>
+        <p:style>
+          <a:lnRef idx="1">
+            <a:schemeClr val="accent1"/>
+          </a:lnRef>
+          <a:fillRef idx="3">
+            <a:schemeClr val="accent1"/>
+          </a:fillRef>
+          <a:effectRef idx="2">
+            <a:schemeClr val="accent1"/>
+          </a:effectRef>
+          <a:fontRef idx="minor">
+            <a:schemeClr val="lt1"/>
+          </a:fontRef>
+        </p:style>
+        <p:txBody>
+          <a:bodyPr rtlCol="0" anchor="ctr"/>
+          <a:lstStyle/>
+          <a:p>
+            <a:pPr algn="ctr"/>
+          </a:p>
+        </p:txBody>
+      </p:sp>
+      <p:sp>
+        <p:nvSpPr>
+          <p:cNvPr id="32" name="Oval 31"/>
+          <p:cNvSpPr/>
+          <p:nvPr/>
+        </p:nvSpPr>
+        <p:spPr>
+          <a:xfrm>
+            <a:off x="7801203" y="4032504"/>
+            <a:ext cx="457200" cy="457200"/>
+          </a:xfrm>
+          <a:prstGeom prst="ellipse">
+            <a:avLst/>
+          </a:prstGeom>
+          <a:solidFill>
+            <a:srgbClr val="FB7185"/>
+          </a:solidFill>
+          <a:ln>
+            <a:noFill/>
+          </a:ln>
+          <a:effectLst/>
+        </p:spPr>
+        <p:style>
+          <a:lnRef idx="1">
+            <a:schemeClr val="accent1"/>
+          </a:lnRef>
+          <a:fillRef idx="3">
+            <a:schemeClr val="accent1"/>
+          </a:fillRef>
+          <a:effectRef idx="2">
+            <a:schemeClr val="accent1"/>
+          </a:effectRef>
+          <a:fontRef idx="minor">
+            <a:schemeClr val="lt1"/>
+          </a:fontRef>
+        </p:style>
+        <p:txBody>
+          <a:bodyPr rtlCol="0" anchor="ctr"/>
+          <a:lstStyle/>
+          <a:p>
+            <a:pPr algn="ctr"/>
+          </a:p>
+        </p:txBody>
+      </p:sp>
+      <p:sp>
+        <p:nvSpPr>
+          <p:cNvPr id="33" name="TextBox 32"/>
+          <p:cNvSpPr txBox="1"/>
+          <p:nvPr/>
+        </p:nvSpPr>
+        <p:spPr>
+          <a:xfrm>
+            <a:off x="7801203" y="4032504"/>
+            <a:ext cx="457200" cy="457200"/>
+          </a:xfrm>
+          <a:prstGeom prst="rect">
+            <a:avLst/>
+          </a:prstGeom>
+          <a:noFill/>
+        </p:spPr>
+        <p:txBody>
+          <a:bodyPr wrap="square" anchor="ctr" lIns="0" rIns="0" tIns="0" bIns="0">
+            <a:spAutoFit/>
+          </a:bodyPr>
+          <a:lstStyle/>
+          <a:p>
+            <a:pPr algn="ctr">
+              <a:spcAft>
+                <a:spcPts val="200"/>
+              </a:spcAft>
+            </a:pPr>
+            <a:r>
+              <a:rPr sz="1200" b="1">
+                <a:solidFill>
+                  <a:srgbClr val="04060F"/>
+                </a:solidFill>
+                <a:latin typeface="Segoe UI Semibold"/>
+              </a:rPr>
+              <a:t>SK</a:t>
+            </a:r>
+          </a:p>
+        </p:txBody>
+      </p:sp>
+      <p:sp>
+        <p:nvSpPr>
+          <p:cNvPr id="34" name="TextBox 33"/>
+          <p:cNvSpPr txBox="1"/>
+          <p:nvPr/>
+        </p:nvSpPr>
+        <p:spPr>
+          <a:xfrm>
+            <a:off x="8368131" y="3950208"/>
+            <a:ext cx="1645920" cy="621792"/>
+          </a:xfrm>
+          <a:prstGeom prst="rect">
+            <a:avLst/>
+          </a:prstGeom>
+          <a:noFill/>
+        </p:spPr>
+        <p:txBody>
+          <a:bodyPr wrap="square" anchor="ctr" lIns="0" rIns="0" tIns="0" bIns="0">
+            <a:spAutoFit/>
+          </a:bodyPr>
+          <a:lstStyle/>
+          <a:p>
+            <a:pPr algn="l">
+              <a:spcAft>
+                <a:spcPts val="200"/>
+              </a:spcAft>
+            </a:pPr>
+            <a:r>
+              <a:rPr sz="1300" b="1">
+                <a:solidFill>
+                  <a:srgbClr val="FFFFFF"/>
+                </a:solidFill>
+                <a:latin typeface="Segoe UI Semibold"/>
+              </a:rPr>
+              <a:t>Sameer Kohli</a:t>
+            </a:r>
+          </a:p>
+        </p:txBody>
+      </p:sp>
+      <p:sp>
+        <p:nvSpPr>
+          <p:cNvPr id="35" name="Rounded Rectangle 34"/>
+          <p:cNvSpPr/>
+          <p:nvPr/>
+        </p:nvSpPr>
+        <p:spPr>
+          <a:xfrm>
+            <a:off x="914400" y="5102352"/>
+            <a:ext cx="10360152" cy="1024128"/>
           </a:xfrm>
           <a:prstGeom prst="roundRect">
             <a:avLst>
@@ -17358,13 +17528,13 @@
       </p:sp>
       <p:sp>
         <p:nvSpPr>
-          <p:cNvPr id="32" name="TextBox 31"/>
-          <p:cNvSpPr txBox="1"/>
-          <p:nvPr/>
-        </p:nvSpPr>
-        <p:spPr>
-          <a:xfrm>
-            <a:off x="914400" y="5394960"/>
+          <p:cNvPr id="36" name="TextBox 35"/>
+          <p:cNvSpPr txBox="1"/>
+          <p:nvPr/>
+        </p:nvSpPr>
+        <p:spPr>
+          <a:xfrm>
+            <a:off x="914400" y="5266944"/>
             <a:ext cx="10360152" cy="274320"/>
           </a:xfrm>
           <a:prstGeom prst="rect">
@@ -17397,13 +17567,13 @@
       </p:sp>
       <p:sp>
         <p:nvSpPr>
-          <p:cNvPr id="33" name="TextBox 32"/>
-          <p:cNvSpPr txBox="1"/>
-          <p:nvPr/>
-        </p:nvSpPr>
-        <p:spPr>
-          <a:xfrm>
-            <a:off x="914400" y="5650992"/>
+          <p:cNvPr id="37" name="TextBox 36"/>
+          <p:cNvSpPr txBox="1"/>
+          <p:nvPr/>
+        </p:nvSpPr>
+        <p:spPr>
+          <a:xfrm>
+            <a:off x="914400" y="5513832"/>
             <a:ext cx="10360152" cy="365760"/>
           </a:xfrm>
           <a:prstGeom prst="rect">
@@ -17436,13 +17606,13 @@
       </p:sp>
       <p:sp>
         <p:nvSpPr>
-          <p:cNvPr id="34" name="TextBox 33"/>
-          <p:cNvSpPr txBox="1"/>
-          <p:nvPr/>
-        </p:nvSpPr>
-        <p:spPr>
-          <a:xfrm>
-            <a:off x="914400" y="6035040"/>
+          <p:cNvPr id="38" name="TextBox 37"/>
+          <p:cNvSpPr txBox="1"/>
+          <p:nvPr/>
+        </p:nvSpPr>
+        <p:spPr>
+          <a:xfrm>
+            <a:off x="914400" y="5888736"/>
             <a:ext cx="10360152" cy="274320"/>
           </a:xfrm>
           <a:prstGeom prst="rect">
@@ -17475,7 +17645,7 @@
       </p:sp>
       <p:sp>
         <p:nvSpPr>
-          <p:cNvPr id="35" name="TextBox 34"/>
+          <p:cNvPr id="39" name="TextBox 38"/>
           <p:cNvSpPr txBox="1"/>
           <p:nvPr/>
         </p:nvSpPr>
@@ -17514,7 +17684,7 @@
       </p:sp>
       <p:sp>
         <p:nvSpPr>
-          <p:cNvPr id="36" name="TextBox 35"/>
+          <p:cNvPr id="40" name="TextBox 39"/>
           <p:cNvSpPr txBox="1"/>
           <p:nvPr/>
         </p:nvSpPr>

</xml_diff>